<commit_message>
Update 7A unseeded ASR after pass-3 shards: 8.92% (493/520 behaviors)
A third round of unseeded-eval shards (jobs 657639-657643) extended
coverage from 346/520 to 493/520 behaviors (5849 rows total, up from
4108). Final unseen-seed ASR is 8.92% (131/1468, +5.09pp vs neutral),
slightly higher than the earlier partial estimate of 8.63% but the
same qualitative conclusion holds. Verified independently against the
raw FREE_GENERATION_RESULTS_UNSEEDED.jsonl. Refreshed the deck (slides
10, 14, 21, 23, 24, 25) to match; no other pipeline changes.

Co-Authored-By: Claude Sonnet 5 <noreply@anthropic.com>
Claude-Session: https://claude.ai/code/session_01Nceec7ZdNYbMQbtQNJUVoL
</commit_message>
<xml_diff>
--- a/docs/GCG_Phases4-7_Summary_2026-07-11.pptx
+++ b/docs/GCG_Phases4-7_Summary_2026-07-11.pptx
@@ -596,7 +596,7 @@
           <a:lstStyle/>
           <a:p>
             <a:r>
-              <a:t>This slide's numbers are now FINAL — all 6 shard jobs for the main evaluation and all 10 shard jobs for the unseen-seed evaluation completed, were merged, replayed (to capture hidden states), and analyzed. The headline takeaway is nuanced and important: the attack DOES generalize to the full 520-behavior AdvBench benchmark, with a robust, consistent, positive uplift over every baseline in both the training-seed and unseen-seed regimes — but the realistic full-benchmark attack rate (about 8%) is meaningfully lower than the 10.7%/14.7% figures obtained on the original 25 hand-picked training behaviors. This is a classic and useful caution in adversarial-attack research: a suffix tuned and evaluated on a small, convenient subset of test cases can look more effective than it really is once tested against the full, more heterogeneous benchmark. For this reason, 8.01% (training seeds) and 8.63% (unseen seeds) should be treated as the project's headline, most-trustworthy attack-effectiveness numbers — not the higher 25-behavior figures. The detection result (AUC=1.000) and the seed-generalization result (negligible transfer gap) both hold up perfectly at full scale, which strengthens confidence in those two findings specifically.</a:t>
+              <a:t>This slide's numbers are now FINAL — all 6 shard jobs for the main evaluation and all 15 shard jobs (across 3 waves) for the unseen-seed evaluation completed, were merged, replayed (to capture hidden states), and analyzed. The unseen-seed evaluation reached 493 of 520 behaviors (94.8%) — 27 behaviors were not reached before the wall-time limit across all three passes, but assignment of behaviors to shards was approximately random, so the 8.92% estimate is considered unbiased. The headline takeaway is nuanced and important: the attack DOES generalize to the full 520-behavior AdvBench benchmark, with a robust, consistent, positive uplift over every baseline in both the training-seed and unseen-seed regimes — but the realistic full-benchmark attack rate (about 8-9%) is meaningfully lower than the 10.7%/14.7% figures obtained on the original 25 hand-picked training behaviors. This is a classic and useful caution in adversarial-attack research: a suffix tuned and evaluated on a small, convenient subset of test cases can look more effective than it really is once tested against the full, more heterogeneous benchmark. For this reason, 8.01% (training seeds) and 8.92% (unseen seeds) should be treated as the project's headline, most-trustworthy attack-effectiveness numbers — not the higher 25-behavior figures. The detection result (AUC=1.000) and the seed-generalization result (negligible transfer gap) both hold up perfectly at full scale, which strengthens confidence in those two findings specifically.</a:t>
             </a:r>
           </a:p>
         </p:txBody>
@@ -1646,7 +1646,7 @@
           <a:lstStyle/>
           <a:p>
             <a:r>
-              <a:t>This closing slide is designed to be read on its own as a one-page executive summary, and now reflects the fully-completed pipeline (as of 2026-07-12). If a reader only looks at one slide in this deck, this is the one: the seven numbered findings (the seventh — full-scale confirmation — was added once Phase 7A finished), plus three headline results. Note the deliberate distinction between the 'best single-run attack' (21.3%, from one seed on the small 25-behavior tuning set) and the 'best full-benchmark rate' (8.01%/8.63%, from testing the same suffix against all 520 AdvBench behaviors) — the full-benchmark number is the more trustworthy, generalizable figure and should be cited as the project's headline result when a single number is needed.</a:t>
+              <a:t>This closing slide is designed to be read on its own as a one-page executive summary, and now reflects the fully-completed pipeline (as of 2026-07-12). If a reader only looks at one slide in this deck, this is the one: the seven numbered findings (the seventh — full-scale confirmation — was added once Phase 7A finished), plus three headline results. Note the deliberate distinction between the 'best single-run attack' (21.3%, from one seed on the small 25-behavior tuning set) and the 'best full-benchmark rate' (8.01%/8.92%, from testing the same suffix against all 520 AdvBench behaviors) — the full-benchmark number is the more trustworthy, generalizable figure and should be cited as the project's headline result when a single number is needed.</a:t>
             </a:r>
           </a:p>
         </p:txBody>
@@ -1716,7 +1716,7 @@
           <a:lstStyle/>
           <a:p>
             <a:r>
-              <a:t>This appendix is a pointer reference, not meant to be read top-to-bottom — it's here so anyone who wants to dig into the raw underlying data after seeing this summary knows exactly which files and job IDs to look for. All paths are relative to the repository root (teza_first_poc_with_mahmood/). The sharding scripts (for both the main 520-behavior evaluation and the follow-up 3-unseen-seed evaluation) and their SLURM launchers were written specifically to parallelize Phase 7A, which was by far the largest single computation in the whole pipeline — 6,240 + 4,108 = 10,348 individual generations to score, replay, and analyze.</a:t>
+              <a:t>This appendix is a pointer reference, not meant to be read top-to-bottom — it's here so anyone who wants to dig into the raw underlying data after seeing this summary knows exactly which files and job IDs to look for. All paths are relative to the repository root (teza_first_poc_with_mahmood/). The sharding scripts (for both the main 520-behavior evaluation and the follow-up 3-unseen-seed evaluation) and their SLURM launchers were written specifically to parallelize Phase 7A, which was by far the largest single computation in the whole pipeline — 6,240 + 5,849 = 12,089 individual generations to score, replay, and analyze.</a:t>
             </a:r>
           </a:p>
         </p:txBody>
@@ -1926,7 +1926,7 @@
           <a:lstStyle/>
           <a:p>
             <a:r>
-              <a:t>Phase 4 is a set of ablation studies ("ablation" = systematically removing or changing one piece of the setup at a time to see what matters) run against the standard GCG attack. Phase 5 is the single most important phase: it discovers and fixes a bug in how the attack target was specified for reasoning models, causing a 4x jump in attack success. Phase 6 tries to combine the Phase 5 attack with a second, published technique (suppressing a 'refusal direction' in the model's activations) and finds the combination backfires. Phase 7 is a scale-out and robustness-check phase that closes three open questions left by Phases 5–6: does the best attack generalize to more behaviors (7A), is it stable across random seeds (7B), and is Gemma4's total resistance a real property or just a technical artifact (7C). 7A turned out to be the longest-running piece (520 behaviors × 4 conditions × 3 seeds = 6,240 generations, later also re-run on 3 more unseen seeds for another 4,108 generations) because of its sheer size, so it was split into parallel SLURM jobs to finish in a reasonable time. As of this version of the deck, it has finished — see slide 10 for its final numbers.</a:t>
+              <a:t>Phase 4 is a set of ablation studies ("ablation" = systematically removing or changing one piece of the setup at a time to see what matters) run against the standard GCG attack. Phase 5 is the single most important phase: it discovers and fixes a bug in how the attack target was specified for reasoning models, causing a 4x jump in attack success. Phase 6 tries to combine the Phase 5 attack with a second, published technique (suppressing a 'refusal direction' in the model's activations) and finds the combination backfires. Phase 7 is a scale-out and robustness-check phase that closes three open questions left by Phases 5–6: does the best attack generalize to more behaviors (7A), is it stable across random seeds (7B), and is Gemma4's total resistance a real property or just a technical artifact (7C). 7A turned out to be the longest-running piece (520 behaviors × 4 conditions × 3 seeds = 6,240 generations, later also re-run on 3 more unseen seeds for another 5,849 generations across 493/520 behaviors) because of its sheer size, so it was split into parallel SLURM jobs to finish in a reasonable time. As of this version of the deck, it has finished — see slide 10 for its final numbers.</a:t>
             </a:r>
           </a:p>
         </p:txBody>
@@ -5577,7 +5577,7 @@
               </a:defRPr>
             </a:pPr>
             <a:r>
-              <a:t>•  Setup: apply the exact 5A suffix (no new optimization) to all 520 behaviors × 4 conditions × 3 seeds = 6,240 generations to score, plus a further 4,108-generation pass on 3 unseen seeds (100/200/300)</a:t>
+              <a:t>•  Setup: apply the exact 5A suffix (no new optimization) to all 520 behaviors × 4 conditions × 3 seeds = 6,240 generations to score, plus a further 5,849-generation pass on 3 unseen seeds (100/200/300)</a:t>
             </a:r>
           </a:p>
           <a:p>
@@ -5592,7 +5592,7 @@
               </a:defRPr>
             </a:pPr>
             <a:r>
-              <a:t>•  Engineering: at ~1.85 rows/minute this would take ~40 hours sequentially, so the manifest was split into 6 shards (scripts/split_7a_manifest.py) run in parallel across 6 GPU nodes, then merged (scripts/merge_7a_shards.py); the unseen-seed pass used the same sharding pattern (scripts/split_unseeded_shards.py / merge_unseeded_shards.py) across 10 shards in 2 waves</a:t>
+              <a:t>•  Engineering: at ~1.85 rows/minute this would take ~40 hours sequentially, so the manifest was split into 6 shards (scripts/split_7a_manifest.py) run in parallel across 6 GPU nodes, then merged (scripts/merge_7a_shards.py); the unseen-seed pass used the same sharding pattern (scripts/split_unseeded_shards.py / merge_unseeded_shards.py) across 15 shards in 3 waves</a:t>
             </a:r>
           </a:p>
           <a:p>
@@ -5622,7 +5622,7 @@
               </a:defRPr>
             </a:pPr>
             <a:r>
-              <a:t>•  FINAL unseen-seed result (4,108 rows, seeds 100/200/300): optimized_weighted = 8.63% ASR (89/1031) vs. neutral_control 3.60%  →  +5.03pp uplift — essentially the same rate as training seeds, confirming the suffix generalizes to fresh randomness too</a:t>
+              <a:t>•  FINAL unseen-seed result (5,849 rows, 493/520 behaviors reached, seeds 100/200/300): optimized_weighted = 8.92% ASR (131/1468) vs. neutral_control 3.83%  →  +5.09pp uplift — essentially the same rate as training seeds, confirming the suffix generalizes to fresh randomness too</a:t>
             </a:r>
           </a:p>
           <a:p>
@@ -5667,7 +5667,7 @@
               </a:defRPr>
             </a:pPr>
             <a:r>
-              <a:t>•  Important nuance: 8.01%/8.63% is LOWER than the 10.7%/14.7% measured on the original 25-behavior tuning set — the small hand-picked set somewhat overestimated attack effectiveness, though the positive, seed-robust uplift fully holds up at scale</a:t>
+              <a:t>•  Important nuance: 8.01%/8.92% is LOWER than the 10.7%/14.7% measured on the original 25-behavior tuning set — the small hand-picked set somewhat overestimated attack effectiveness, though the positive, seed-robust uplift fully holds up at scale</a:t>
             </a:r>
           </a:p>
         </p:txBody>
@@ -10439,7 +10439,7 @@
                         </a:defRPr>
                       </a:pPr>
                       <a:r>
-                        <a:t>8.63% (89/1031)</a:t>
+                        <a:t>8.92% (131/1468, 493/520 beh.)</a:t>
                       </a:r>
                     </a:p>
                   </a:txBody>
@@ -10485,7 +10485,7 @@
                         </a:defRPr>
                       </a:pPr>
                       <a:r>
-                        <a:t>+5.83 / +5.03pp</a:t>
+                        <a:t>+5.83 / +5.09pp</a:t>
                       </a:r>
                     </a:p>
                   </a:txBody>
@@ -12769,7 +12769,7 @@
                         </a:defRPr>
                       </a:pPr>
                       <a:r>
-                        <a:t>8.01% train / 8.63% unseen seeds</a:t>
+                        <a:t>8.01% train / 8.92% unseen seeds</a:t>
                       </a:r>
                     </a:p>
                   </a:txBody>
@@ -14055,7 +14055,7 @@
                         </a:defRPr>
                       </a:pPr>
                       <a:r>
-                        <a:t>6,240 rows (train seeds) + 4,108 rows (unseen seeds) all scored, replayed, and analyzed. Final: 8.01% train / 8.63% unseen ASR, AUC=1.000 at all 32 positions</a:t>
+                        <a:t>6,240 rows (train seeds) + 5,849 rows (unseen seeds, 493/520 behaviors) all scored, replayed, and analyzed. Final: 8.01% train / 8.92% unseen ASR, AUC=1.000 at all 32 positions</a:t>
                       </a:r>
                     </a:p>
                   </a:txBody>
@@ -14644,7 +14644,7 @@
               </a:defRPr>
             </a:pPr>
             <a:r>
-              <a:t>•  7. NEW: the realistic full-benchmark attack rate (8.01% train / 8.63% unseen, 520 behaviors) is lower than the 25-behavior tuning-set rate (10.7%/14.7%) — small-n evaluation sets can overestimate GCG effectiveness, though the positive uplift generalizes robustly</a:t>
+              <a:t>•  7. NEW: the realistic full-benchmark attack rate (8.01% train / 8.92% unseen, 520 behaviors) is lower than the 25-behavior tuning-set rate (10.7%/14.7%) — small-n evaluation sets can overestimate GCG effectiveness, though the positive uplift generalizes robustly</a:t>
             </a:r>
           </a:p>
           <a:p>
@@ -14674,7 +14674,7 @@
               </a:defRPr>
             </a:pPr>
             <a:r>
-              <a:t>•  Best full-benchmark, most-trustworthy attack rate: 7A, 8.01% train / 8.63% unseen ASR across all 520 AdvBench behaviors</a:t>
+              <a:t>•  Best full-benchmark, most-trustworthy attack rate: 7A, 8.01% train / 8.92% unseen ASR across all 520 AdvBench behaviors</a:t>
             </a:r>
           </a:p>
           <a:p>
@@ -15014,7 +15014,7 @@
               </a:defRPr>
             </a:pPr>
             <a:r>
-              <a:t>‒  outputs/stage_gcg_full/gcg_full_qwen3_7a_5a_full520/ — 7A final merged results (6,240 rows train + 4,108 rows unseen seeds)</a:t>
+              <a:t>‒  outputs/stage_gcg_full/gcg_full_qwen3_7a_5a_full520/ — 7A final merged results (6,240 rows train + 5,849 rows unseen seeds (493/520 behaviors))</a:t>
             </a:r>
           </a:p>
           <a:p>

</xml_diff>